<commit_message>
docs: 표지 카피를 hi_story로
hi와 story가 붙어 history가 된다. 덱이 세우는 논지가 내 가방의 역사이자
MCM의 역사라는 것이라 표지에서 그 말을 먼저 한다.

기존 카피 '흠을 지우지 않습니다. 나의 것으로 만듭니다'는 부제로 내렸다.
버리기엔 아까운 문장이고, 표제 아래에서 무슨 이야기인지 바로 설명해 준다.

Co-Authored-By: Claude Opus 5 <noreply@anthropic.com>
</commit_message>
<xml_diff>
--- a/docs/ir/MCM_Luxury_Book_IR.pptx
+++ b/docs/ir/MCM_Luxury_Book_IR.pptx
@@ -535,7 +535,7 @@
           <a:p>
             <a:r>
               <a:rPr lang="en-US" dirty="0"/>
-              <a:t>럭셔리는 새것일 때 가장 비쌉니다. 그래서 사람들은 쓰기를 두려워합니다. 저희는 그 방향을 뒤집었습니다.</a:t>
+              <a:t/>
             </a:r>
             <a:endParaRPr lang="en-US" dirty="0"/>
           </a:p>
@@ -3883,8 +3883,8 @@
         </p:nvSpPr>
         <p:spPr>
           <a:xfrm>
-            <a:off x="868680" y="2286000"/>
-            <a:ext cx="10607040" cy="2011680"/>
+            <a:off x="868680" y="2212848"/>
+            <a:ext cx="10607040" cy="548640"/>
           </a:xfrm>
           <a:prstGeom prst="rect">
             <a:avLst/>
@@ -3897,13 +3897,10 @@
           <a:lstStyle/>
           <a:p>
             <a:pPr indent="0" marL="0">
-              <a:lnSpc>
-                <a:spcPts val="7400"/>
-              </a:lnSpc>
-              <a:buNone/>
-            </a:pPr>
-            <a:r>
-              <a:rPr lang="en-US" sz="5200" b="1" dirty="0">
+              <a:buNone/>
+            </a:pPr>
+            <a:r>
+              <a:rPr lang="en-US" sz="2600" dirty="0">
                 <a:solidFill>
                   <a:srgbClr val="FFFFFF"/>
                 </a:solidFill>
@@ -3911,19 +3908,52 @@
                 <a:ea typeface="Apple SD Gothic Neo" pitchFamily="34" charset="-122"/>
                 <a:cs typeface="Apple SD Gothic Neo" pitchFamily="34" charset="-120"/>
               </a:rPr>
-              <a:t>흠을 지우지 않습니다.</a:t>
-            </a:r>
-            <a:endParaRPr lang="en-US" sz="5200" dirty="0"/>
-          </a:p>
+              <a:t>MCM과 함께하는</a:t>
+            </a:r>
+            <a:endParaRPr lang="en-US" sz="2600" dirty="0"/>
+          </a:p>
+        </p:txBody>
+      </p:sp>
+      <p:sp>
+        <p:nvSpPr>
+          <p:cNvPr id="5" name="Text 2"/>
+          <p:cNvSpPr/>
+          <p:nvPr/>
+        </p:nvSpPr>
+        <p:spPr>
+          <a:xfrm>
+            <a:off x="822960" y="2761488"/>
+            <a:ext cx="10607040" cy="1371600"/>
+          </a:xfrm>
+          <a:prstGeom prst="rect">
+            <a:avLst/>
+          </a:prstGeom>
+          <a:noFill/>
+          <a:ln/>
+        </p:spPr>
+        <p:txBody>
+          <a:bodyPr wrap="square" lIns="0" tIns="0" rIns="0" bIns="0" rtlCol="0" anchor="ctr"/>
+          <a:lstStyle/>
           <a:p>
             <a:pPr indent="0" marL="0">
-              <a:lnSpc>
-                <a:spcPts val="7400"/>
-              </a:lnSpc>
-              <a:buNone/>
-            </a:pPr>
-            <a:r>
-              <a:rPr lang="en-US" sz="5200" b="1" dirty="0">
+              <a:buNone/>
+            </a:pPr>
+            <a:r>
+              <a:rPr lang="en-US" sz="7600" b="1" spc="-100" kern="0" dirty="0">
+                <a:solidFill>
+                  <a:srgbClr val="FFFFFF"/>
+                </a:solidFill>
+                <a:latin typeface="Apple SD Gothic Neo" pitchFamily="34" charset="0"/>
+                <a:ea typeface="Apple SD Gothic Neo" pitchFamily="34" charset="-122"/>
+                <a:cs typeface="Apple SD Gothic Neo" pitchFamily="34" charset="-120"/>
+              </a:rPr>
+              <a:t>hi</a:t>
+            </a:r>
+            <a:pPr indent="0" marL="0">
+              <a:buNone/>
+            </a:pPr>
+            <a:r>
+              <a:rPr lang="en-US" sz="7600" b="1" spc="-100" kern="0" dirty="0">
                 <a:solidFill>
                   <a:srgbClr val="C4915F"/>
                 </a:solidFill>
@@ -3931,21 +3961,60 @@
                 <a:ea typeface="Apple SD Gothic Neo" pitchFamily="34" charset="-122"/>
                 <a:cs typeface="Apple SD Gothic Neo" pitchFamily="34" charset="-120"/>
               </a:rPr>
-              <a:t>나의 것으로 만듭니다</a:t>
-            </a:r>
-            <a:endParaRPr lang="en-US" sz="5200" dirty="0"/>
-          </a:p>
-        </p:txBody>
-      </p:sp>
-      <p:sp>
-        <p:nvSpPr>
-          <p:cNvPr id="5" name="Text 2"/>
-          <p:cNvSpPr/>
-          <p:nvPr/>
-        </p:nvSpPr>
-        <p:spPr>
-          <a:xfrm>
-            <a:off x="896112" y="4937760"/>
+              <a:t>_story</a:t>
+            </a:r>
+            <a:endParaRPr lang="en-US" sz="7600" dirty="0"/>
+          </a:p>
+        </p:txBody>
+      </p:sp>
+      <p:sp>
+        <p:nvSpPr>
+          <p:cNvPr id="6" name="Text 3"/>
+          <p:cNvSpPr/>
+          <p:nvPr/>
+        </p:nvSpPr>
+        <p:spPr>
+          <a:xfrm>
+            <a:off x="896112" y="4443984"/>
+            <a:ext cx="10058400" cy="384048"/>
+          </a:xfrm>
+          <a:prstGeom prst="rect">
+            <a:avLst/>
+          </a:prstGeom>
+          <a:noFill/>
+          <a:ln/>
+        </p:spPr>
+        <p:txBody>
+          <a:bodyPr wrap="square" lIns="0" tIns="0" rIns="0" bIns="0" rtlCol="0" anchor="ctr"/>
+          <a:lstStyle/>
+          <a:p>
+            <a:pPr indent="0" marL="0">
+              <a:buNone/>
+            </a:pPr>
+            <a:r>
+              <a:rPr lang="en-US" sz="1700" dirty="0">
+                <a:solidFill>
+                  <a:srgbClr val="9A8F84"/>
+                </a:solidFill>
+                <a:latin typeface="Apple SD Gothic Neo" pitchFamily="34" charset="0"/>
+                <a:ea typeface="Apple SD Gothic Neo" pitchFamily="34" charset="-122"/>
+                <a:cs typeface="Apple SD Gothic Neo" pitchFamily="34" charset="-120"/>
+              </a:rPr>
+              <a:t>흠을 지우지 않습니다. 나의 것으로 만듭니다</a:t>
+            </a:r>
+            <a:endParaRPr lang="en-US" sz="1700" dirty="0"/>
+          </a:p>
+        </p:txBody>
+      </p:sp>
+      <p:sp>
+        <p:nvSpPr>
+          <p:cNvPr id="7" name="Text 4"/>
+          <p:cNvSpPr/>
+          <p:nvPr/>
+        </p:nvSpPr>
+        <p:spPr>
+          <a:xfrm>
+            <a:off x="896112" y="4974336"/>
             <a:ext cx="10058400" cy="310896"/>
           </a:xfrm>
           <a:prstGeom prst="rect">

</xml_diff>